<commit_message>
Refine related work slide text
</commit_message>
<xml_diff>
--- a/UnrealZoo_组会汇报_前八页版.pptx
+++ b/UnrealZoo_组会汇报_前八页版.pptx
@@ -856,7 +856,7 @@
           <a:lstStyle/>
           <a:p>
             <a:r>
-              <a:t>图片解读：这一页没有单独放原图，以结构化文字解释论文的系统架构。演讲时可画出“策略—客户端—服务端—环境”的闭环：策略输出动作，客户端发送请求，引擎返回视觉和状态。</a:t>
+              <a:t>这一页不使用表格，而是用四段文字说明相关工作的差异。先介绍室内模拟器，再介绍驾驶模拟器和真实街景方法，最后说明 UnrealZoo 的定位。重点是让听众理解：UnrealZoo 不是简单增加地图数量，而是把场景范围、实体类型和交互任务放在同一个开放世界平台中。</a:t>
             </a:r>
           </a:p>
         </p:txBody>
@@ -4452,7 +4452,7 @@
                 </a:solidFill>
                 <a:latin typeface="Microsoft YaHei"/>
               </a:rPr>
-              <a:t>3. UnrealCV+：把游戏引擎变成实验平台</a:t>
+              <a:t>4. 相关工作：现有模拟器难以覆盖开放世界</a:t>
             </a:r>
           </a:p>
         </p:txBody>
@@ -4486,7 +4486,7 @@
                 </a:solidFill>
                 <a:latin typeface="Microsoft YaHei"/>
               </a:rPr>
-              <a:t>系统方法</a:t>
+              <a:t>相关工作</a:t>
             </a:r>
           </a:p>
         </p:txBody>
@@ -4499,7 +4499,7 @@
         </p:nvSpPr>
         <p:spPr>
           <a:xfrm>
-            <a:off x="731520" y="1408176"/>
+            <a:off x="749808" y="1417320"/>
             <a:ext cx="128016" cy="128016"/>
           </a:xfrm>
           <a:prstGeom prst="ellipse">
@@ -4542,8 +4542,42 @@
         </p:nvSpPr>
         <p:spPr>
           <a:xfrm>
-            <a:off x="987552" y="1325880"/>
-            <a:ext cx="5486400" cy="566928"/>
+            <a:off x="1024128" y="1325880"/>
+            <a:ext cx="1874519" cy="320040"/>
+          </a:xfrm>
+          <a:prstGeom prst="rect">
+            <a:avLst/>
+          </a:prstGeom>
+          <a:noFill/>
+        </p:spPr>
+        <p:txBody>
+          <a:bodyPr wrap="square">
+            <a:spAutoFit/>
+          </a:bodyPr>
+          <a:lstStyle/>
+          <a:p>
+            <a:r>
+              <a:rPr sz="1900" b="1">
+                <a:solidFill>
+                  <a:srgbClr val="2B72A5"/>
+                </a:solidFill>
+                <a:latin typeface="Microsoft YaHei"/>
+              </a:rPr>
+              <a:t>室内模拟器</a:t>
+            </a:r>
+          </a:p>
+        </p:txBody>
+      </p:sp>
+      <p:sp>
+        <p:nvSpPr>
+          <p:cNvPr id="7" name="TextBox 6"/>
+          <p:cNvSpPr txBox="1"/>
+          <p:nvPr/>
+        </p:nvSpPr>
+        <p:spPr>
+          <a:xfrm>
+            <a:off x="2788920" y="1325880"/>
+            <a:ext cx="8549640" cy="566928"/>
           </a:xfrm>
           <a:prstGeom prst="rect">
             <a:avLst/>
@@ -4563,20 +4597,20 @@
                 </a:solidFill>
                 <a:latin typeface="Microsoft YaHei"/>
               </a:rPr>
-              <a:t>Python 客户端—Unreal Engine 服务端：统一获取观测、发送动作与修改环境。</a:t>
+              <a:t>VirtualHome、AI2THOR 和 Habitat 主要关注室内活动，场景规模和环境变化有限。</a:t>
             </a:r>
           </a:p>
         </p:txBody>
       </p:sp>
       <p:sp>
         <p:nvSpPr>
-          <p:cNvPr id="7" name="Oval 6"/>
+          <p:cNvPr id="8" name="Oval 7"/>
           <p:cNvSpPr/>
           <p:nvPr/>
         </p:nvSpPr>
         <p:spPr>
           <a:xfrm>
-            <a:off x="731520" y="2231136"/>
+            <a:off x="749808" y="2350008"/>
             <a:ext cx="128016" cy="128016"/>
           </a:xfrm>
           <a:prstGeom prst="ellipse">
@@ -4613,14 +4647,48 @@
       </p:sp>
       <p:sp>
         <p:nvSpPr>
-          <p:cNvPr id="8" name="TextBox 7"/>
+          <p:cNvPr id="9" name="TextBox 8"/>
           <p:cNvSpPr txBox="1"/>
           <p:nvPr/>
         </p:nvSpPr>
         <p:spPr>
           <a:xfrm>
-            <a:off x="987552" y="2148840"/>
-            <a:ext cx="5486400" cy="566928"/>
+            <a:off x="1024128" y="2258568"/>
+            <a:ext cx="1874519" cy="320040"/>
+          </a:xfrm>
+          <a:prstGeom prst="rect">
+            <a:avLst/>
+          </a:prstGeom>
+          <a:noFill/>
+        </p:spPr>
+        <p:txBody>
+          <a:bodyPr wrap="square">
+            <a:spAutoFit/>
+          </a:bodyPr>
+          <a:lstStyle/>
+          <a:p>
+            <a:r>
+              <a:rPr sz="1900" b="1">
+                <a:solidFill>
+                  <a:srgbClr val="2B72A5"/>
+                </a:solidFill>
+                <a:latin typeface="Microsoft YaHei"/>
+              </a:rPr>
+              <a:t>驾驶模拟器</a:t>
+            </a:r>
+          </a:p>
+        </p:txBody>
+      </p:sp>
+      <p:sp>
+        <p:nvSpPr>
+          <p:cNvPr id="10" name="TextBox 9"/>
+          <p:cNvSpPr txBox="1"/>
+          <p:nvPr/>
+        </p:nvSpPr>
+        <p:spPr>
+          <a:xfrm>
+            <a:off x="2788920" y="2258568"/>
+            <a:ext cx="8549640" cy="566928"/>
           </a:xfrm>
           <a:prstGeom prst="rect">
             <a:avLst/>
@@ -4640,20 +4708,20 @@
                 </a:solidFill>
                 <a:latin typeface="Microsoft YaHei"/>
               </a:rPr>
-              <a:t>批量传输、并行处理和优化接口，降低大场景、多智能体下的通信开销。</a:t>
+              <a:t>CARLA 和 AirSim 主要服务于自动驾驶，实体类型和任务形式相对集中。</a:t>
             </a:r>
           </a:p>
         </p:txBody>
       </p:sp>
       <p:sp>
         <p:nvSpPr>
-          <p:cNvPr id="9" name="Oval 8"/>
+          <p:cNvPr id="11" name="Oval 10"/>
           <p:cNvSpPr/>
           <p:nvPr/>
         </p:nvSpPr>
         <p:spPr>
           <a:xfrm>
-            <a:off x="731520" y="3054096"/>
+            <a:off x="749808" y="3282696"/>
             <a:ext cx="128016" cy="128016"/>
           </a:xfrm>
           <a:prstGeom prst="ellipse">
@@ -4690,14 +4758,48 @@
       </p:sp>
       <p:sp>
         <p:nvSpPr>
-          <p:cNvPr id="10" name="TextBox 9"/>
+          <p:cNvPr id="12" name="TextBox 11"/>
           <p:cNvSpPr txBox="1"/>
           <p:nvPr/>
         </p:nvSpPr>
         <p:spPr>
           <a:xfrm>
-            <a:off x="987552" y="2971800"/>
-            <a:ext cx="5486400" cy="566928"/>
+            <a:off x="1024128" y="3191256"/>
+            <a:ext cx="1874519" cy="320040"/>
+          </a:xfrm>
+          <a:prstGeom prst="rect">
+            <a:avLst/>
+          </a:prstGeom>
+          <a:noFill/>
+        </p:spPr>
+        <p:txBody>
+          <a:bodyPr wrap="square">
+            <a:spAutoFit/>
+          </a:bodyPr>
+          <a:lstStyle/>
+          <a:p>
+            <a:r>
+              <a:rPr sz="1900" b="1">
+                <a:solidFill>
+                  <a:srgbClr val="2B72A5"/>
+                </a:solidFill>
+                <a:latin typeface="Microsoft YaHei"/>
+              </a:rPr>
+              <a:t>真实街景方法</a:t>
+            </a:r>
+          </a:p>
+        </p:txBody>
+      </p:sp>
+      <p:sp>
+        <p:nvSpPr>
+          <p:cNvPr id="13" name="TextBox 12"/>
+          <p:cNvSpPr txBox="1"/>
+          <p:nvPr/>
+        </p:nvSpPr>
+        <p:spPr>
+          <a:xfrm>
+            <a:off x="2788920" y="3191256"/>
+            <a:ext cx="8549640" cy="566928"/>
           </a:xfrm>
           <a:prstGeom prst="rect">
             <a:avLst/>
@@ -4717,20 +4819,20 @@
                 </a:solidFill>
                 <a:latin typeface="Microsoft YaHei"/>
               </a:rPr>
-              <a:t>提供 Gym 接口、演示采集、环境增强、人口控制、时间膨胀与分布式训练工具。</a:t>
+              <a:t>V-IRL 等方法可以利用真实街景，但静态图像组成限制了物理交互能力。</a:t>
             </a:r>
           </a:p>
         </p:txBody>
       </p:sp>
       <p:sp>
         <p:nvSpPr>
-          <p:cNvPr id="11" name="Oval 10"/>
+          <p:cNvPr id="14" name="Oval 13"/>
           <p:cNvSpPr/>
           <p:nvPr/>
         </p:nvSpPr>
         <p:spPr>
           <a:xfrm>
-            <a:off x="731520" y="3877056"/>
+            <a:off x="749808" y="4215383"/>
             <a:ext cx="128016" cy="128016"/>
           </a:xfrm>
           <a:prstGeom prst="ellipse">
@@ -4767,14 +4869,48 @@
       </p:sp>
       <p:sp>
         <p:nvSpPr>
-          <p:cNvPr id="12" name="TextBox 11"/>
+          <p:cNvPr id="15" name="TextBox 14"/>
           <p:cNvSpPr txBox="1"/>
           <p:nvPr/>
         </p:nvSpPr>
         <p:spPr>
           <a:xfrm>
-            <a:off x="987552" y="3794760"/>
-            <a:ext cx="5486400" cy="566928"/>
+            <a:off x="1024128" y="4123944"/>
+            <a:ext cx="1874519" cy="320040"/>
+          </a:xfrm>
+          <a:prstGeom prst="rect">
+            <a:avLst/>
+          </a:prstGeom>
+          <a:noFill/>
+        </p:spPr>
+        <p:txBody>
+          <a:bodyPr wrap="square">
+            <a:spAutoFit/>
+          </a:bodyPr>
+          <a:lstStyle/>
+          <a:p>
+            <a:r>
+              <a:rPr sz="1900" b="1">
+                <a:solidFill>
+                  <a:srgbClr val="2B72A5"/>
+                </a:solidFill>
+                <a:latin typeface="Microsoft YaHei"/>
+              </a:rPr>
+              <a:t>UnrealZoo 的定位</a:t>
+            </a:r>
+          </a:p>
+        </p:txBody>
+      </p:sp>
+      <p:sp>
+        <p:nvSpPr>
+          <p:cNvPr id="16" name="TextBox 15"/>
+          <p:cNvSpPr txBox="1"/>
+          <p:nvPr/>
+        </p:nvSpPr>
+        <p:spPr>
+          <a:xfrm>
+            <a:off x="2788920" y="4123944"/>
+            <a:ext cx="8549640" cy="566928"/>
           </a:xfrm>
           <a:prstGeom prst="rect">
             <a:avLst/>
@@ -4794,7 +4930,7 @@
                 </a:solidFill>
                 <a:latin typeface="Microsoft YaHei"/>
               </a:rPr>
-              <a:t>核心设计目标：可扩展、可复现、适合闭环控制。</a:t>
+              <a:t>覆盖室内、建筑、社区、城市和自然景观，并同时支持多种实体、导航、跟踪与多智能体交互。</a:t>
             </a:r>
           </a:p>
         </p:txBody>

</xml_diff>